<commit_message>
docs(paper): use chemical-engineering vocabulary throughout the note, SI and figures
- operating conditions instead of operating inputs; conditions, variables and
  data instead of inputs; parametric analyses instead of what-if; first-ranked
  candidate instead of leader; balanced weighting instead of profile; current
  quotations instead of the live basis; documented and source-specific
  preparations instead of curated variants; published prices instead of
  evidence; archived and recalculation instead of frozen and replay; dry
  product mass, operator labor and equipment time in the batch costing
- shared status labels, Figure S2/S3/S7 labels and the Figure 3(a) deck label
  follow the same wording; the literature-review document is regenerated
- numbers and the word count (4,999 of 5,000) are unchanged

Audit entry H61.

Co-Authored-By: Claude Fable 5.1 <noreply@anthropic.com>
</commit_message>
<xml_diff>
--- a/docs/paper/diagram-sources-2026-09-16/fig3_manufacturing.pptx
+++ b/docs/paper/diagram-sources-2026-09-16/fig3_manufacturing.pptx
@@ -4120,8 +4120,8 @@
         </p:nvSpPr>
         <p:spPr>
           <a:xfrm>
-            <a:off x="5423909" y="152742"/>
-            <a:ext cx="984084" cy="219702"/>
+            <a:off x="5374705" y="152742"/>
+            <a:ext cx="1082492" cy="219702"/>
           </a:xfrm>
           <a:prstGeom prst="rect">
             <a:avLst/>
@@ -4156,7 +4156,7 @@
                 <a:ea typeface="Arial"/>
                 <a:cs typeface="Arial"/>
               </a:rPr>
-              <a:t>Dry output</a:t>
+              <a:t>Dry product</a:t>
             </a:r>
           </a:p>
         </p:txBody>

</xml_diff>